<commit_message>
update week 12 homework
</commit_message>
<xml_diff>
--- a/week-12-streamlit_caching_and_data_pipeline/week-12-slides-v2.pptx
+++ b/week-12-streamlit_caching_and_data_pipeline/week-12-slides-v2.pptx
@@ -3478,6 +3478,18 @@
   <p:clrMapOvr>
     <a:masterClrMapping/>
   </p:clrMapOvr>
+  <mc:AlternateContent xmlns:mc="http://schemas.openxmlformats.org/markup-compatibility/2006">
+    <mc:Choice xmlns:p14="http://schemas.microsoft.com/office/powerpoint/2010/main" Requires="p14">
+      <p:transition spd="slow" p14:dur="2000">
+        <p:cut/>
+      </p:transition>
+    </mc:Choice>
+    <mc:Fallback>
+      <p:transition spd="slow">
+        <p:cut/>
+      </p:transition>
+    </mc:Fallback>
+  </mc:AlternateContent>
 </p:sld>
 </file>
 
@@ -4030,6 +4042,18 @@
   <p:clrMapOvr>
     <a:masterClrMapping/>
   </p:clrMapOvr>
+  <mc:AlternateContent xmlns:mc="http://schemas.openxmlformats.org/markup-compatibility/2006">
+    <mc:Choice xmlns:p14="http://schemas.microsoft.com/office/powerpoint/2010/main" Requires="p14">
+      <p:transition spd="slow" p14:dur="2000">
+        <p:cut/>
+      </p:transition>
+    </mc:Choice>
+    <mc:Fallback>
+      <p:transition spd="slow">
+        <p:cut/>
+      </p:transition>
+    </mc:Fallback>
+  </mc:AlternateContent>
 </p:sld>
 </file>
 
@@ -5101,6 +5125,18 @@
   <p:clrMapOvr>
     <a:masterClrMapping/>
   </p:clrMapOvr>
+  <mc:AlternateContent xmlns:mc="http://schemas.openxmlformats.org/markup-compatibility/2006">
+    <mc:Choice xmlns:p14="http://schemas.microsoft.com/office/powerpoint/2010/main" Requires="p14">
+      <p:transition spd="slow" p14:dur="2000">
+        <p:cut/>
+      </p:transition>
+    </mc:Choice>
+    <mc:Fallback>
+      <p:transition spd="slow">
+        <p:cut/>
+      </p:transition>
+    </mc:Fallback>
+  </mc:AlternateContent>
 </p:sld>
 </file>
 
@@ -5869,6 +5905,18 @@
   <p:clrMapOvr>
     <a:masterClrMapping/>
   </p:clrMapOvr>
+  <mc:AlternateContent xmlns:mc="http://schemas.openxmlformats.org/markup-compatibility/2006">
+    <mc:Choice xmlns:p14="http://schemas.microsoft.com/office/powerpoint/2010/main" Requires="p14">
+      <p:transition spd="slow" p14:dur="2000">
+        <p:cut/>
+      </p:transition>
+    </mc:Choice>
+    <mc:Fallback>
+      <p:transition spd="slow">
+        <p:cut/>
+      </p:transition>
+    </mc:Fallback>
+  </mc:AlternateContent>
 </p:sld>
 </file>
 
@@ -6858,6 +6906,18 @@
   <p:clrMapOvr>
     <a:masterClrMapping/>
   </p:clrMapOvr>
+  <mc:AlternateContent xmlns:mc="http://schemas.openxmlformats.org/markup-compatibility/2006">
+    <mc:Choice xmlns:p14="http://schemas.microsoft.com/office/powerpoint/2010/main" Requires="p14">
+      <p:transition spd="slow" p14:dur="2000">
+        <p:cut/>
+      </p:transition>
+    </mc:Choice>
+    <mc:Fallback>
+      <p:transition spd="slow">
+        <p:cut/>
+      </p:transition>
+    </mc:Fallback>
+  </mc:AlternateContent>
 </p:sld>
 </file>
 
@@ -8016,6 +8076,18 @@
   <p:clrMapOvr>
     <a:masterClrMapping/>
   </p:clrMapOvr>
+  <mc:AlternateContent xmlns:mc="http://schemas.openxmlformats.org/markup-compatibility/2006">
+    <mc:Choice xmlns:p14="http://schemas.microsoft.com/office/powerpoint/2010/main" Requires="p14">
+      <p:transition spd="slow" p14:dur="2000">
+        <p:cut/>
+      </p:transition>
+    </mc:Choice>
+    <mc:Fallback>
+      <p:transition spd="slow">
+        <p:cut/>
+      </p:transition>
+    </mc:Fallback>
+  </mc:AlternateContent>
 </p:sld>
 </file>
 
@@ -8674,6 +8746,18 @@
   <p:clrMapOvr>
     <a:masterClrMapping/>
   </p:clrMapOvr>
+  <mc:AlternateContent xmlns:mc="http://schemas.openxmlformats.org/markup-compatibility/2006">
+    <mc:Choice xmlns:p14="http://schemas.microsoft.com/office/powerpoint/2010/main" Requires="p14">
+      <p:transition spd="slow" p14:dur="2000">
+        <p:cut/>
+      </p:transition>
+    </mc:Choice>
+    <mc:Fallback>
+      <p:transition spd="slow">
+        <p:cut/>
+      </p:transition>
+    </mc:Fallback>
+  </mc:AlternateContent>
 </p:sld>
 </file>
 
@@ -9622,6 +9706,18 @@
   <p:clrMapOvr>
     <a:masterClrMapping/>
   </p:clrMapOvr>
+  <mc:AlternateContent xmlns:mc="http://schemas.openxmlformats.org/markup-compatibility/2006">
+    <mc:Choice xmlns:p14="http://schemas.microsoft.com/office/powerpoint/2010/main" Requires="p14">
+      <p:transition spd="slow" p14:dur="2000">
+        <p:cut/>
+      </p:transition>
+    </mc:Choice>
+    <mc:Fallback>
+      <p:transition spd="slow">
+        <p:cut/>
+      </p:transition>
+    </mc:Fallback>
+  </mc:AlternateContent>
 </p:sld>
 </file>
 
@@ -10545,6 +10641,18 @@
   <p:clrMapOvr>
     <a:masterClrMapping/>
   </p:clrMapOvr>
+  <mc:AlternateContent xmlns:mc="http://schemas.openxmlformats.org/markup-compatibility/2006">
+    <mc:Choice xmlns:p14="http://schemas.microsoft.com/office/powerpoint/2010/main" Requires="p14">
+      <p:transition spd="slow" p14:dur="2000">
+        <p:cut/>
+      </p:transition>
+    </mc:Choice>
+    <mc:Fallback>
+      <p:transition spd="slow">
+        <p:cut/>
+      </p:transition>
+    </mc:Fallback>
+  </mc:AlternateContent>
 </p:sld>
 </file>
 
@@ -11579,6 +11687,18 @@
   <p:clrMapOvr>
     <a:masterClrMapping/>
   </p:clrMapOvr>
+  <mc:AlternateContent xmlns:mc="http://schemas.openxmlformats.org/markup-compatibility/2006">
+    <mc:Choice xmlns:p14="http://schemas.microsoft.com/office/powerpoint/2010/main" Requires="p14">
+      <p:transition spd="slow" p14:dur="2000">
+        <p:cut/>
+      </p:transition>
+    </mc:Choice>
+    <mc:Fallback>
+      <p:transition spd="slow">
+        <p:cut/>
+      </p:transition>
+    </mc:Fallback>
+  </mc:AlternateContent>
 </p:sld>
 </file>
 
@@ -11999,6 +12119,18 @@
   <p:clrMapOvr>
     <a:masterClrMapping/>
   </p:clrMapOvr>
+  <mc:AlternateContent xmlns:mc="http://schemas.openxmlformats.org/markup-compatibility/2006">
+    <mc:Choice xmlns:p14="http://schemas.microsoft.com/office/powerpoint/2010/main" Requires="p14">
+      <p:transition spd="slow" p14:dur="2000">
+        <p:cut/>
+      </p:transition>
+    </mc:Choice>
+    <mc:Fallback>
+      <p:transition spd="slow">
+        <p:cut/>
+      </p:transition>
+    </mc:Fallback>
+  </mc:AlternateContent>
 </p:sld>
 </file>
 
@@ -12676,6 +12808,18 @@
   <p:clrMapOvr>
     <a:masterClrMapping/>
   </p:clrMapOvr>
+  <mc:AlternateContent xmlns:mc="http://schemas.openxmlformats.org/markup-compatibility/2006">
+    <mc:Choice xmlns:p14="http://schemas.microsoft.com/office/powerpoint/2010/main" Requires="p14">
+      <p:transition spd="slow" p14:dur="2000">
+        <p:cut/>
+      </p:transition>
+    </mc:Choice>
+    <mc:Fallback>
+      <p:transition spd="slow">
+        <p:cut/>
+      </p:transition>
+    </mc:Fallback>
+  </mc:AlternateContent>
 </p:sld>
 </file>
 
@@ -13507,6 +13651,18 @@
   <p:clrMapOvr>
     <a:masterClrMapping/>
   </p:clrMapOvr>
+  <mc:AlternateContent xmlns:mc="http://schemas.openxmlformats.org/markup-compatibility/2006">
+    <mc:Choice xmlns:p14="http://schemas.microsoft.com/office/powerpoint/2010/main" Requires="p14">
+      <p:transition spd="slow" p14:dur="2000">
+        <p:cut/>
+      </p:transition>
+    </mc:Choice>
+    <mc:Fallback>
+      <p:transition spd="slow">
+        <p:cut/>
+      </p:transition>
+    </mc:Fallback>
+  </mc:AlternateContent>
 </p:sld>
 </file>
 
@@ -14010,6 +14166,18 @@
   <p:clrMapOvr>
     <a:masterClrMapping/>
   </p:clrMapOvr>
+  <mc:AlternateContent xmlns:mc="http://schemas.openxmlformats.org/markup-compatibility/2006">
+    <mc:Choice xmlns:p14="http://schemas.microsoft.com/office/powerpoint/2010/main" Requires="p14">
+      <p:transition spd="slow" p14:dur="2000">
+        <p:cut/>
+      </p:transition>
+    </mc:Choice>
+    <mc:Fallback>
+      <p:transition spd="slow">
+        <p:cut/>
+      </p:transition>
+    </mc:Fallback>
+  </mc:AlternateContent>
 </p:sld>
 </file>
 
@@ -14219,6 +14387,18 @@
   <p:clrMapOvr>
     <a:masterClrMapping/>
   </p:clrMapOvr>
+  <mc:AlternateContent xmlns:mc="http://schemas.openxmlformats.org/markup-compatibility/2006">
+    <mc:Choice xmlns:p14="http://schemas.microsoft.com/office/powerpoint/2010/main" Requires="p14">
+      <p:transition spd="slow" p14:dur="2000">
+        <p:cut/>
+      </p:transition>
+    </mc:Choice>
+    <mc:Fallback>
+      <p:transition spd="slow">
+        <p:cut/>
+      </p:transition>
+    </mc:Fallback>
+  </mc:AlternateContent>
 </p:sld>
 </file>
 
@@ -15396,6 +15576,18 @@
   <p:clrMapOvr>
     <a:masterClrMapping/>
   </p:clrMapOvr>
+  <mc:AlternateContent xmlns:mc="http://schemas.openxmlformats.org/markup-compatibility/2006">
+    <mc:Choice xmlns:p14="http://schemas.microsoft.com/office/powerpoint/2010/main" Requires="p14">
+      <p:transition spd="slow" p14:dur="2000">
+        <p:cut/>
+      </p:transition>
+    </mc:Choice>
+    <mc:Fallback>
+      <p:transition spd="slow">
+        <p:cut/>
+      </p:transition>
+    </mc:Fallback>
+  </mc:AlternateContent>
 </p:sld>
 </file>
 
@@ -17028,6 +17220,18 @@
   <p:clrMapOvr>
     <a:masterClrMapping/>
   </p:clrMapOvr>
+  <mc:AlternateContent xmlns:mc="http://schemas.openxmlformats.org/markup-compatibility/2006">
+    <mc:Choice xmlns:p14="http://schemas.microsoft.com/office/powerpoint/2010/main" Requires="p14">
+      <p:transition spd="slow" p14:dur="2000">
+        <p:cut/>
+      </p:transition>
+    </mc:Choice>
+    <mc:Fallback>
+      <p:transition spd="slow">
+        <p:cut/>
+      </p:transition>
+    </mc:Fallback>
+  </mc:AlternateContent>
 </p:sld>
 </file>
 
@@ -17671,6 +17875,18 @@
   <p:clrMapOvr>
     <a:masterClrMapping/>
   </p:clrMapOvr>
+  <mc:AlternateContent xmlns:mc="http://schemas.openxmlformats.org/markup-compatibility/2006">
+    <mc:Choice xmlns:p14="http://schemas.microsoft.com/office/powerpoint/2010/main" Requires="p14">
+      <p:transition spd="slow" p14:dur="2000">
+        <p:cut/>
+      </p:transition>
+    </mc:Choice>
+    <mc:Fallback>
+      <p:transition spd="slow">
+        <p:cut/>
+      </p:transition>
+    </mc:Fallback>
+  </mc:AlternateContent>
 </p:sld>
 </file>
 
@@ -18063,6 +18279,18 @@
   <p:clrMapOvr>
     <a:masterClrMapping/>
   </p:clrMapOvr>
+  <mc:AlternateContent xmlns:mc="http://schemas.openxmlformats.org/markup-compatibility/2006">
+    <mc:Choice xmlns:p14="http://schemas.microsoft.com/office/powerpoint/2010/main" Requires="p14">
+      <p:transition spd="slow" p14:dur="2000">
+        <p:cut/>
+      </p:transition>
+    </mc:Choice>
+    <mc:Fallback>
+      <p:transition spd="slow">
+        <p:cut/>
+      </p:transition>
+    </mc:Fallback>
+  </mc:AlternateContent>
 </p:sld>
 </file>
 
@@ -18250,7 +18478,7 @@
         <p:spPr>
           <a:xfrm>
             <a:off x="822960" y="1874519"/>
-            <a:ext cx="10515600" cy="1097280"/>
+            <a:ext cx="10515600" cy="767646"/>
           </a:xfrm>
           <a:prstGeom prst="rect">
             <a:avLst/>
@@ -18269,7 +18497,7 @@
               </a:lnSpc>
             </a:pPr>
             <a:r>
-              <a:rPr sz="1800" b="1">
+              <a:rPr sz="1800" b="1" dirty="0">
                 <a:solidFill>
                   <a:srgbClr val="0D9B9B"/>
                 </a:solidFill>
@@ -18278,14 +18506,20 @@
               <a:t>▸  </a:t>
             </a:r>
             <a:r>
-              <a:rPr sz="1800">
+              <a:rPr sz="1800" dirty="0" err="1">
                 <a:solidFill>
                   <a:srgbClr val="1A1A2E"/>
                 </a:solidFill>
                 <a:latin typeface="Microsoft JhengHei"/>
               </a:rPr>
-              <a:t>重新定位：不是「論文 Table 1」，而是資料品質的診斷儀器</a:t>
-            </a:r>
+              <a:t>重新定位：資料品質的診斷儀器</a:t>
+            </a:r>
+            <a:endParaRPr sz="1800" dirty="0">
+              <a:solidFill>
+                <a:srgbClr val="1A1A2E"/>
+              </a:solidFill>
+              <a:latin typeface="Microsoft JhengHei"/>
+            </a:endParaRPr>
           </a:p>
           <a:p>
             <a:pPr algn="l">
@@ -18297,7 +18531,7 @@
               </a:spcBef>
             </a:pPr>
             <a:r>
-              <a:rPr sz="1800" b="1">
+              <a:rPr sz="1800" b="1" dirty="0">
                 <a:solidFill>
                   <a:srgbClr val="0D9B9B"/>
                 </a:solidFill>
@@ -18306,13 +18540,22 @@
               <a:t>▸  </a:t>
             </a:r>
             <a:r>
-              <a:rPr sz="1800">
+              <a:rPr sz="1800" dirty="0" err="1">
                 <a:solidFill>
                   <a:srgbClr val="1A1A2E"/>
                 </a:solidFill>
                 <a:latin typeface="Microsoft JhengHei"/>
               </a:rPr>
-              <a:t>五件每次都做的事 →</a:t>
+              <a:t>五件每次都做的事</a:t>
+            </a:r>
+            <a:r>
+              <a:rPr sz="1800" dirty="0">
+                <a:solidFill>
+                  <a:srgbClr val="1A1A2E"/>
+                </a:solidFill>
+                <a:latin typeface="Microsoft JhengHei"/>
+              </a:rPr>
+              <a:t> →</a:t>
             </a:r>
           </a:p>
         </p:txBody>
@@ -18850,6 +19093,18 @@
   <p:clrMapOvr>
     <a:masterClrMapping/>
   </p:clrMapOvr>
+  <mc:AlternateContent xmlns:mc="http://schemas.openxmlformats.org/markup-compatibility/2006">
+    <mc:Choice xmlns:p14="http://schemas.microsoft.com/office/powerpoint/2010/main" Requires="p14">
+      <p:transition spd="slow" p14:dur="2000">
+        <p:cut/>
+      </p:transition>
+    </mc:Choice>
+    <mc:Fallback>
+      <p:transition spd="slow">
+        <p:cut/>
+      </p:transition>
+    </mc:Fallback>
+  </mc:AlternateContent>
 </p:sld>
 </file>
 
@@ -19795,6 +20050,18 @@
   <p:clrMapOvr>
     <a:masterClrMapping/>
   </p:clrMapOvr>
+  <mc:AlternateContent xmlns:mc="http://schemas.openxmlformats.org/markup-compatibility/2006">
+    <mc:Choice xmlns:p14="http://schemas.microsoft.com/office/powerpoint/2010/main" Requires="p14">
+      <p:transition spd="slow" p14:dur="2000">
+        <p:cut/>
+      </p:transition>
+    </mc:Choice>
+    <mc:Fallback>
+      <p:transition spd="slow">
+        <p:cut/>
+      </p:transition>
+    </mc:Fallback>
+  </mc:AlternateContent>
 </p:sld>
 </file>
 
@@ -20818,6 +21085,18 @@
   <p:clrMapOvr>
     <a:masterClrMapping/>
   </p:clrMapOvr>
+  <mc:AlternateContent xmlns:mc="http://schemas.openxmlformats.org/markup-compatibility/2006">
+    <mc:Choice xmlns:p14="http://schemas.microsoft.com/office/powerpoint/2010/main" Requires="p14">
+      <p:transition spd="slow" p14:dur="2000">
+        <p:cut/>
+      </p:transition>
+    </mc:Choice>
+    <mc:Fallback>
+      <p:transition spd="slow">
+        <p:cut/>
+      </p:transition>
+    </mc:Fallback>
+  </mc:AlternateContent>
 </p:sld>
 </file>
 
@@ -21203,6 +21482,18 @@
   <p:clrMapOvr>
     <a:masterClrMapping/>
   </p:clrMapOvr>
+  <mc:AlternateContent xmlns:mc="http://schemas.openxmlformats.org/markup-compatibility/2006">
+    <mc:Choice xmlns:p14="http://schemas.microsoft.com/office/powerpoint/2010/main" Requires="p14">
+      <p:transition spd="slow" p14:dur="2000">
+        <p:cut/>
+      </p:transition>
+    </mc:Choice>
+    <mc:Fallback>
+      <p:transition spd="slow">
+        <p:cut/>
+      </p:transition>
+    </mc:Fallback>
+  </mc:AlternateContent>
 </p:sld>
 </file>
 
@@ -21630,6 +21921,18 @@
   <p:clrMapOvr>
     <a:masterClrMapping/>
   </p:clrMapOvr>
+  <mc:AlternateContent xmlns:mc="http://schemas.openxmlformats.org/markup-compatibility/2006">
+    <mc:Choice xmlns:p14="http://schemas.microsoft.com/office/powerpoint/2010/main" Requires="p14">
+      <p:transition spd="slow" p14:dur="2000">
+        <p:cut/>
+      </p:transition>
+    </mc:Choice>
+    <mc:Fallback>
+      <p:transition spd="slow">
+        <p:cut/>
+      </p:transition>
+    </mc:Fallback>
+  </mc:AlternateContent>
 </p:sld>
 </file>
 
@@ -22771,6 +23074,18 @@
   <p:clrMapOvr>
     <a:masterClrMapping/>
   </p:clrMapOvr>
+  <mc:AlternateContent xmlns:mc="http://schemas.openxmlformats.org/markup-compatibility/2006">
+    <mc:Choice xmlns:p14="http://schemas.microsoft.com/office/powerpoint/2010/main" Requires="p14">
+      <p:transition spd="slow" p14:dur="2000">
+        <p:cut/>
+      </p:transition>
+    </mc:Choice>
+    <mc:Fallback>
+      <p:transition spd="slow">
+        <p:cut/>
+      </p:transition>
+    </mc:Fallback>
+  </mc:AlternateContent>
 </p:sld>
 </file>
 
@@ -23653,6 +23968,18 @@
   <p:clrMapOvr>
     <a:masterClrMapping/>
   </p:clrMapOvr>
+  <mc:AlternateContent xmlns:mc="http://schemas.openxmlformats.org/markup-compatibility/2006">
+    <mc:Choice xmlns:p14="http://schemas.microsoft.com/office/powerpoint/2010/main" Requires="p14">
+      <p:transition spd="slow" p14:dur="2000">
+        <p:cut/>
+      </p:transition>
+    </mc:Choice>
+    <mc:Fallback>
+      <p:transition spd="slow">
+        <p:cut/>
+      </p:transition>
+    </mc:Fallback>
+  </mc:AlternateContent>
 </p:sld>
 </file>
 
@@ -24698,6 +25025,18 @@
   <p:clrMapOvr>
     <a:masterClrMapping/>
   </p:clrMapOvr>
+  <mc:AlternateContent xmlns:mc="http://schemas.openxmlformats.org/markup-compatibility/2006">
+    <mc:Choice xmlns:p14="http://schemas.microsoft.com/office/powerpoint/2010/main" Requires="p14">
+      <p:transition spd="slow" p14:dur="2000">
+        <p:cut/>
+      </p:transition>
+    </mc:Choice>
+    <mc:Fallback>
+      <p:transition spd="slow">
+        <p:cut/>
+      </p:transition>
+    </mc:Fallback>
+  </mc:AlternateContent>
 </p:sld>
 </file>
 
@@ -25403,6 +25742,18 @@
   <p:clrMapOvr>
     <a:masterClrMapping/>
   </p:clrMapOvr>
+  <mc:AlternateContent xmlns:mc="http://schemas.openxmlformats.org/markup-compatibility/2006">
+    <mc:Choice xmlns:p14="http://schemas.microsoft.com/office/powerpoint/2010/main" Requires="p14">
+      <p:transition spd="slow" p14:dur="2000">
+        <p:cut/>
+      </p:transition>
+    </mc:Choice>
+    <mc:Fallback>
+      <p:transition spd="slow">
+        <p:cut/>
+      </p:transition>
+    </mc:Fallback>
+  </mc:AlternateContent>
 </p:sld>
 </file>
 
@@ -25830,6 +26181,18 @@
   <p:clrMapOvr>
     <a:masterClrMapping/>
   </p:clrMapOvr>
+  <mc:AlternateContent xmlns:mc="http://schemas.openxmlformats.org/markup-compatibility/2006">
+    <mc:Choice xmlns:p14="http://schemas.microsoft.com/office/powerpoint/2010/main" Requires="p14">
+      <p:transition spd="slow" p14:dur="2000">
+        <p:cut/>
+      </p:transition>
+    </mc:Choice>
+    <mc:Fallback>
+      <p:transition spd="slow">
+        <p:cut/>
+      </p:transition>
+    </mc:Fallback>
+  </mc:AlternateContent>
 </p:sld>
 </file>
 
@@ -26721,6 +27084,18 @@
   <p:clrMapOvr>
     <a:masterClrMapping/>
   </p:clrMapOvr>
+  <mc:AlternateContent xmlns:mc="http://schemas.openxmlformats.org/markup-compatibility/2006">
+    <mc:Choice xmlns:p14="http://schemas.microsoft.com/office/powerpoint/2010/main" Requires="p14">
+      <p:transition spd="slow" p14:dur="2000">
+        <p:cut/>
+      </p:transition>
+    </mc:Choice>
+    <mc:Fallback>
+      <p:transition spd="slow">
+        <p:cut/>
+      </p:transition>
+    </mc:Fallback>
+  </mc:AlternateContent>
 </p:sld>
 </file>
 
@@ -27484,6 +27859,18 @@
   <p:clrMapOvr>
     <a:masterClrMapping/>
   </p:clrMapOvr>
+  <mc:AlternateContent xmlns:mc="http://schemas.openxmlformats.org/markup-compatibility/2006">
+    <mc:Choice xmlns:p14="http://schemas.microsoft.com/office/powerpoint/2010/main" Requires="p14">
+      <p:transition spd="slow" p14:dur="2000">
+        <p:cut/>
+      </p:transition>
+    </mc:Choice>
+    <mc:Fallback>
+      <p:transition spd="slow">
+        <p:cut/>
+      </p:transition>
+    </mc:Fallback>
+  </mc:AlternateContent>
 </p:sld>
 </file>
 
@@ -28182,6 +28569,18 @@
   <p:clrMapOvr>
     <a:masterClrMapping/>
   </p:clrMapOvr>
+  <mc:AlternateContent xmlns:mc="http://schemas.openxmlformats.org/markup-compatibility/2006">
+    <mc:Choice xmlns:p14="http://schemas.microsoft.com/office/powerpoint/2010/main" Requires="p14">
+      <p:transition spd="slow" p14:dur="2000">
+        <p:cut/>
+      </p:transition>
+    </mc:Choice>
+    <mc:Fallback>
+      <p:transition spd="slow">
+        <p:cut/>
+      </p:transition>
+    </mc:Fallback>
+  </mc:AlternateContent>
 </p:sld>
 </file>
 
@@ -28810,6 +29209,18 @@
   <p:clrMapOvr>
     <a:masterClrMapping/>
   </p:clrMapOvr>
+  <mc:AlternateContent xmlns:mc="http://schemas.openxmlformats.org/markup-compatibility/2006">
+    <mc:Choice xmlns:p14="http://schemas.microsoft.com/office/powerpoint/2010/main" Requires="p14">
+      <p:transition spd="slow" p14:dur="2000">
+        <p:cut/>
+      </p:transition>
+    </mc:Choice>
+    <mc:Fallback>
+      <p:transition spd="slow">
+        <p:cut/>
+      </p:transition>
+    </mc:Fallback>
+  </mc:AlternateContent>
 </p:sld>
 </file>
 
@@ -29223,6 +29634,18 @@
   <p:clrMapOvr>
     <a:masterClrMapping/>
   </p:clrMapOvr>
+  <mc:AlternateContent xmlns:mc="http://schemas.openxmlformats.org/markup-compatibility/2006">
+    <mc:Choice xmlns:p14="http://schemas.microsoft.com/office/powerpoint/2010/main" Requires="p14">
+      <p:transition spd="slow" p14:dur="2000">
+        <p:cut/>
+      </p:transition>
+    </mc:Choice>
+    <mc:Fallback>
+      <p:transition spd="slow">
+        <p:cut/>
+      </p:transition>
+    </mc:Fallback>
+  </mc:AlternateContent>
 </p:sld>
 </file>
 
@@ -29922,6 +30345,18 @@
   <p:clrMapOvr>
     <a:masterClrMapping/>
   </p:clrMapOvr>
+  <mc:AlternateContent xmlns:mc="http://schemas.openxmlformats.org/markup-compatibility/2006">
+    <mc:Choice xmlns:p14="http://schemas.microsoft.com/office/powerpoint/2010/main" Requires="p14">
+      <p:transition spd="slow" p14:dur="2000">
+        <p:cut/>
+      </p:transition>
+    </mc:Choice>
+    <mc:Fallback>
+      <p:transition spd="slow">
+        <p:cut/>
+      </p:transition>
+    </mc:Fallback>
+  </mc:AlternateContent>
 </p:sld>
 </file>
 
@@ -30560,6 +30995,18 @@
   <p:clrMapOvr>
     <a:masterClrMapping/>
   </p:clrMapOvr>
+  <mc:AlternateContent xmlns:mc="http://schemas.openxmlformats.org/markup-compatibility/2006">
+    <mc:Choice xmlns:p14="http://schemas.microsoft.com/office/powerpoint/2010/main" Requires="p14">
+      <p:transition spd="slow" p14:dur="2000">
+        <p:cut/>
+      </p:transition>
+    </mc:Choice>
+    <mc:Fallback>
+      <p:transition spd="slow">
+        <p:cut/>
+      </p:transition>
+    </mc:Fallback>
+  </mc:AlternateContent>
 </p:sld>
 </file>
 
@@ -31663,6 +32110,18 @@
   <p:clrMapOvr>
     <a:masterClrMapping/>
   </p:clrMapOvr>
+  <mc:AlternateContent xmlns:mc="http://schemas.openxmlformats.org/markup-compatibility/2006">
+    <mc:Choice xmlns:p14="http://schemas.microsoft.com/office/powerpoint/2010/main" Requires="p14">
+      <p:transition spd="slow" p14:dur="2000">
+        <p:cut/>
+      </p:transition>
+    </mc:Choice>
+    <mc:Fallback>
+      <p:transition spd="slow">
+        <p:cut/>
+      </p:transition>
+    </mc:Fallback>
+  </mc:AlternateContent>
 </p:sld>
 </file>
 
@@ -32945,6 +33404,18 @@
   <p:clrMapOvr>
     <a:masterClrMapping/>
   </p:clrMapOvr>
+  <mc:AlternateContent xmlns:mc="http://schemas.openxmlformats.org/markup-compatibility/2006">
+    <mc:Choice xmlns:p14="http://schemas.microsoft.com/office/powerpoint/2010/main" Requires="p14">
+      <p:transition spd="slow" p14:dur="2000">
+        <p:cut/>
+      </p:transition>
+    </mc:Choice>
+    <mc:Fallback>
+      <p:transition spd="slow">
+        <p:cut/>
+      </p:transition>
+    </mc:Fallback>
+  </mc:AlternateContent>
 </p:sld>
 </file>
 
@@ -33154,6 +33625,18 @@
   <p:clrMapOvr>
     <a:masterClrMapping/>
   </p:clrMapOvr>
+  <mc:AlternateContent xmlns:mc="http://schemas.openxmlformats.org/markup-compatibility/2006">
+    <mc:Choice xmlns:p14="http://schemas.microsoft.com/office/powerpoint/2010/main" Requires="p14">
+      <p:transition spd="slow" p14:dur="2000">
+        <p:cut/>
+      </p:transition>
+    </mc:Choice>
+    <mc:Fallback>
+      <p:transition spd="slow">
+        <p:cut/>
+      </p:transition>
+    </mc:Fallback>
+  </mc:AlternateContent>
 </p:sld>
 </file>
 
@@ -34026,6 +34509,18 @@
   <p:clrMapOvr>
     <a:masterClrMapping/>
   </p:clrMapOvr>
+  <mc:AlternateContent xmlns:mc="http://schemas.openxmlformats.org/markup-compatibility/2006">
+    <mc:Choice xmlns:p14="http://schemas.microsoft.com/office/powerpoint/2010/main" Requires="p14">
+      <p:transition spd="slow" p14:dur="2000">
+        <p:cut/>
+      </p:transition>
+    </mc:Choice>
+    <mc:Fallback>
+      <p:transition spd="slow">
+        <p:cut/>
+      </p:transition>
+    </mc:Fallback>
+  </mc:AlternateContent>
 </p:sld>
 </file>
 
@@ -35244,6 +35739,18 @@
   <p:clrMapOvr>
     <a:masterClrMapping/>
   </p:clrMapOvr>
+  <mc:AlternateContent xmlns:mc="http://schemas.openxmlformats.org/markup-compatibility/2006">
+    <mc:Choice xmlns:p14="http://schemas.microsoft.com/office/powerpoint/2010/main" Requires="p14">
+      <p:transition spd="slow" p14:dur="2000">
+        <p:cut/>
+      </p:transition>
+    </mc:Choice>
+    <mc:Fallback>
+      <p:transition spd="slow">
+        <p:cut/>
+      </p:transition>
+    </mc:Fallback>
+  </mc:AlternateContent>
 </p:sld>
 </file>
 
@@ -36726,6 +37233,18 @@
   <p:clrMapOvr>
     <a:masterClrMapping/>
   </p:clrMapOvr>
+  <mc:AlternateContent xmlns:mc="http://schemas.openxmlformats.org/markup-compatibility/2006">
+    <mc:Choice xmlns:p14="http://schemas.microsoft.com/office/powerpoint/2010/main" Requires="p14">
+      <p:transition spd="slow" p14:dur="2000">
+        <p:cut/>
+      </p:transition>
+    </mc:Choice>
+    <mc:Fallback>
+      <p:transition spd="slow">
+        <p:cut/>
+      </p:transition>
+    </mc:Fallback>
+  </mc:AlternateContent>
 </p:sld>
 </file>
 

</xml_diff>